<commit_message>
Apply BDO 2023 brand rules and add study-driven fixes (v0.2.0)
Rules come from the BDO 2023 guidelines and PowerPoint template: Trebuchet MS,
26 pt red sentence-case titles at the template position, the full palette
with the no-tints rule for red and burgundy. Measuring 27 real proposals led
to new actions: Fix all, Snap colours, Tidy text (justified text and double
spaces), Remove empty text boxes (with confirm), a client-ready score and a
check for leftover draft text. docs/STUDY_FINDINGS.md keeps aggregate counts
only.

Co-Authored-By: Claude Opus 5.5 <noreply@anthropic.com>
Claude-Session: https://claude.ai/code/session_01XRxPtGHbSsBqUSaMdzU8AF
</commit_message>
<xml_diff>
--- a/tests/decks/messy.pptx
+++ b/tests/decks/messy.pptx
@@ -3121,8 +3121,8 @@
         </p:nvSpPr>
         <p:spPr>
           <a:xfrm>
-            <a:off x="457200" y="1270000"/>
-            <a:ext cx="11277600" cy="3810000"/>
+            <a:off x="482600" y="1714500"/>
+            <a:ext cx="11226800" cy="3810000"/>
           </a:xfrm>
           <a:prstGeom prst="rect">
             <a:avLst/>
@@ -3136,8 +3136,8 @@
           <a:lstStyle/>
           <a:p>
             <a:r>
-              <a:rPr sz="1400" b="0">
-                <a:latin typeface="Arial"/>
+              <a:rPr sz="1200" b="0">
+                <a:latin typeface="Trebuchet MS"/>
               </a:rPr>
               <a:t>Sample body text at the brand size.</a:t>
             </a:r>
@@ -3170,8 +3170,8 @@
         </p:nvSpPr>
         <p:spPr>
           <a:xfrm>
-            <a:off x="762000" y="635000"/>
-            <a:ext cx="8890000" cy="762000"/>
+            <a:off x="762000" y="381000"/>
+            <a:ext cx="8890000" cy="558800"/>
           </a:xfrm>
           <a:prstGeom prst="rect">
             <a:avLst/>
@@ -3185,10 +3185,13 @@
           <a:lstStyle/>
           <a:p>
             <a:r>
-              <a:rPr sz="3000" b="1">
-                <a:latin typeface="Calibri"/>
+              <a:rPr sz="2200" b="1">
+                <a:solidFill>
+                  <a:srgbClr val="FF0000"/>
+                </a:solidFill>
+                <a:latin typeface="Trebuchet MS"/>
               </a:rPr>
-              <a:t>MARKET OVERVIEW FOR FY26</a:t>
+              <a:t>OUR UNDERSTANDING OF THE PMI SCOPE</a:t>
             </a:r>
           </a:p>
         </p:txBody>
@@ -3201,8 +3204,8 @@
         </p:nvSpPr>
         <p:spPr>
           <a:xfrm>
-            <a:off x="457200" y="1651000"/>
-            <a:ext cx="11277600" cy="2540000"/>
+            <a:off x="482600" y="1714500"/>
+            <a:ext cx="11226800" cy="2540000"/>
           </a:xfrm>
           <a:prstGeom prst="rect">
             <a:avLst/>
@@ -3216,10 +3219,10 @@
           <a:lstStyle/>
           <a:p>
             <a:r>
-              <a:rPr sz="1600" b="0">
-                <a:latin typeface="Calibri"/>
+              <a:rPr sz="1100" b="0">
+                <a:latin typeface="Aptos"/>
               </a:rPr>
-              <a:t>Body in Calibri at 16 pt.</a:t>
+              <a:t>Body text in Aptos at 11 pt.</a:t>
             </a:r>
           </a:p>
         </p:txBody>
@@ -3250,8 +3253,8 @@
         </p:nvSpPr>
         <p:spPr>
           <a:xfrm>
-            <a:off x="457200" y="355600"/>
-            <a:ext cx="11277600" cy="660400"/>
+            <a:off x="482600" y="596900"/>
+            <a:ext cx="11226800" cy="355600"/>
           </a:xfrm>
           <a:prstGeom prst="rect">
             <a:avLst/>
@@ -3265,10 +3268,13 @@
           <a:lstStyle/>
           <a:p>
             <a:r>
-              <a:rPr sz="2400" b="1">
-                <a:latin typeface="Arial"/>
+              <a:rPr sz="2600" b="0">
+                <a:solidFill>
+                  <a:srgbClr val="ED1A3B"/>
+                </a:solidFill>
+                <a:latin typeface="Trebuchet MS"/>
               </a:rPr>
-              <a:t>Scope of work</a:t>
+              <a:t>Approach And Methodology</a:t>
             </a:r>
           </a:p>
         </p:txBody>
@@ -3281,7 +3287,7 @@
         </p:nvSpPr>
         <p:spPr>
           <a:xfrm>
-            <a:off x="457200" y="1270000"/>
+            <a:off x="482600" y="1714500"/>
             <a:ext cx="5334000" cy="2540000"/>
           </a:xfrm>
           <a:prstGeom prst="rect">
@@ -3295,14 +3301,15 @@
           </a:bodyPr>
           <a:lstStyle/>
           <a:p>
+            <a:pPr algn="just"/>
             <a:r>
               <a:rPr sz="1200" b="0">
                 <a:solidFill>
-                  <a:srgbClr val="1E90FF"/>
+                  <a:srgbClr val="002060"/>
                 </a:solidFill>
-                <a:latin typeface="Arial"/>
+                <a:latin typeface="Trebuchet MS"/>
               </a:rPr>
-              <a:t>Body at 12 pt in an off-brand blue.</a:t>
+              <a:t>Phase 1  covers diagnostics and the  day-one plan.</a:t>
             </a:r>
           </a:p>
         </p:txBody>
@@ -3315,7 +3322,7 @@
         </p:nvSpPr>
         <p:spPr>
           <a:xfrm>
-            <a:off x="6096000" y="1270000"/>
+            <a:off x="6096000" y="1714500"/>
             <a:ext cx="5334000" cy="2540000"/>
           </a:xfrm>
           <a:prstGeom prst="rect">
@@ -3330,10 +3337,10 @@
           <a:lstStyle/>
           <a:p>
             <a:r>
-              <a:rPr sz="1800" b="0">
-                <a:latin typeface="Arial"/>
+              <a:rPr sz="1400" b="0">
+                <a:latin typeface="Trebuchet MS"/>
               </a:rPr>
-              <a:t>Body at 18 pt.</a:t>
+              <a:t>Body at 14 pt.</a:t>
             </a:r>
           </a:p>
         </p:txBody>
@@ -3346,8 +3353,8 @@
         </p:nvSpPr>
         <p:spPr>
           <a:xfrm>
-            <a:off x="457200" y="4191000"/>
-            <a:ext cx="5334000" cy="508000"/>
+            <a:off x="482600" y="4826000"/>
+            <a:ext cx="5334000" cy="381000"/>
           </a:xfrm>
           <a:prstGeom prst="rect">
             <a:avLst/>
@@ -3361,10 +3368,10 @@
           <a:lstStyle/>
           <a:p>
             <a:r>
-              <a:rPr sz="800" b="0">
-                <a:latin typeface="Arial"/>
+              <a:rPr sz="700" b="0">
+                <a:latin typeface="Trebuchet MS"/>
               </a:rPr>
-              <a:t>Tiny 8 pt note in the middle of the slide.</a:t>
+              <a:t>Tiny 7 pt note in the middle of the slide.</a:t>
             </a:r>
           </a:p>
         </p:txBody>
@@ -3395,8 +3402,8 @@
         </p:nvSpPr>
         <p:spPr>
           <a:xfrm>
-            <a:off x="457200" y="355600"/>
-            <a:ext cx="11277600" cy="660400"/>
+            <a:off x="482600" y="596900"/>
+            <a:ext cx="11226800" cy="355600"/>
           </a:xfrm>
           <a:prstGeom prst="rect">
             <a:avLst/>
@@ -3410,10 +3417,13 @@
           <a:lstStyle/>
           <a:p>
             <a:r>
-              <a:rPr sz="2400" b="1">
-                <a:latin typeface="Arial"/>
+              <a:rPr sz="2600" b="0">
+                <a:solidFill>
+                  <a:srgbClr val="E81A3B"/>
+                </a:solidFill>
+                <a:latin typeface="Trebuchet MS"/>
               </a:rPr>
-              <a:t>Approach</a:t>
+              <a:t>Commercials</a:t>
             </a:r>
           </a:p>
         </p:txBody>
@@ -3426,7 +3436,7 @@
         </p:nvSpPr>
         <p:spPr>
           <a:xfrm>
-            <a:off x="457200" y="1270000"/>
+            <a:off x="482600" y="1714500"/>
             <a:ext cx="3810000" cy="1270000"/>
           </a:xfrm>
           <a:prstGeom prst="rect">
@@ -3441,8 +3451,8 @@
           <a:lstStyle/>
           <a:p>
             <a:r>
-              <a:rPr sz="1400" b="0">
-                <a:latin typeface="Arial"/>
+              <a:rPr sz="1200" b="0">
+                <a:latin typeface="Trebuchet MS"/>
               </a:rPr>
               <a:t/>
             </a:r>
@@ -3472,8 +3482,8 @@
           <a:lstStyle/>
           <a:p>
             <a:r>
-              <a:rPr sz="1400" b="0">
-                <a:latin typeface="Arial"/>
+              <a:rPr sz="1200" b="0">
+                <a:latin typeface="Trebuchet MS"/>
               </a:rPr>
               <a:t>This box runs off the right edge.</a:t>
             </a:r>
@@ -3488,7 +3498,38 @@
         </p:nvSpPr>
         <p:spPr>
           <a:xfrm>
-            <a:off x="457200" y="6413500"/>
+            <a:off x="482600" y="3302000"/>
+            <a:ext cx="7620000" cy="508000"/>
+          </a:xfrm>
+          <a:prstGeom prst="rect">
+            <a:avLst/>
+          </a:prstGeom>
+          <a:noFill/>
+        </p:spPr>
+        <p:txBody>
+          <a:bodyPr wrap="none">
+            <a:spAutoFit/>
+          </a:bodyPr>
+          <a:lstStyle/>
+          <a:p>
+            <a:r>
+              <a:rPr sz="1200" b="0">
+                <a:latin typeface="Trebuchet MS"/>
+              </a:rPr>
+              <a:t>Professional fee: INR XX lakh, start date TBD</a:t>
+            </a:r>
+          </a:p>
+        </p:txBody>
+      </p:sp>
+      <p:sp>
+        <p:nvSpPr>
+          <p:cNvPr id="6" name="TextBox 5"/>
+          <p:cNvSpPr txBox="1"/>
+          <p:nvPr/>
+        </p:nvSpPr>
+        <p:spPr>
+          <a:xfrm>
+            <a:off x="482600" y="6540500"/>
             <a:ext cx="7620000" cy="254000"/>
           </a:xfrm>
           <a:prstGeom prst="rect">
@@ -3503,8 +3544,8 @@
           <a:lstStyle/>
           <a:p>
             <a:r>
-              <a:rPr sz="900" b="0">
-                <a:latin typeface="Arial"/>
+              <a:rPr sz="800" b="0">
+                <a:latin typeface="Trebuchet MS"/>
               </a:rPr>
               <a:t>Source: synthetic test data</a:t>
             </a:r>
@@ -3537,8 +3578,8 @@
         </p:nvSpPr>
         <p:spPr>
           <a:xfrm>
-            <a:off x="457200" y="3810000"/>
-            <a:ext cx="11277600" cy="762000"/>
+            <a:off x="482600" y="3810000"/>
+            <a:ext cx="11226800" cy="762000"/>
           </a:xfrm>
           <a:prstGeom prst="rect">
             <a:avLst/>
@@ -3552,8 +3593,8 @@
           <a:lstStyle/>
           <a:p>
             <a:r>
-              <a:rPr sz="1400" b="0">
-                <a:latin typeface="Arial"/>
+              <a:rPr sz="1200" b="0">
+                <a:latin typeface="Trebuchet MS"/>
               </a:rPr>
               <a:t>Only body text, low on the slide.</a:t>
             </a:r>

</xml_diff>